<commit_message>
🎵 Update README with live prototype URL + latest deck
- Prototype live at: https://v0-spotify-app-development-omega.vercel.app/
- Updated README with feature table, business impact metrics, deploy guide
- Latest strategy deck (PDF + PPTX) with NotebookLM watermark on all slides
- Fixed emoji rendering issues on slide 2 (no more question marks)
- Prototype source JSX updated
</commit_message>
<xml_diff>
--- a/deck/spotify_strategy_deck.pptx
+++ b/deck/spotify_strategy_deck.pptx
@@ -1939,6 +1939,78 @@
           </a:p>
         </p:txBody>
       </p:sp>
+      <p:sp>
+        <p:nvSpPr>
+          <p:cNvPr id="20" name="Shape 18"/>
+          <p:cNvSpPr/>
+          <p:nvPr/>
+        </p:nvSpPr>
+        <p:spPr>
+          <a:xfrm>
+            <a:off x="7132320" y="4919472"/>
+            <a:ext cx="1965960" cy="201168"/>
+          </a:xfrm>
+          <a:prstGeom prst="rect">
+            <a:avLst/>
+          </a:prstGeom>
+          <a:solidFill>
+            <a:srgbClr val="E8F4FD"/>
+          </a:solidFill>
+          <a:ln w="6350">
+            <a:solidFill>
+              <a:srgbClr val="4285F4"/>
+            </a:solidFill>
+            <a:prstDash val="solid"/>
+          </a:ln>
+        </p:spPr>
+      </p:sp>
+      <p:sp>
+        <p:nvSpPr>
+          <p:cNvPr id="21" name="Text 19"/>
+          <p:cNvSpPr/>
+          <p:nvPr/>
+        </p:nvSpPr>
+        <p:spPr>
+          <a:xfrm>
+            <a:off x="7150608" y="4924044"/>
+            <a:ext cx="1920240" cy="182880"/>
+          </a:xfrm>
+          <a:prstGeom prst="rect">
+            <a:avLst/>
+          </a:prstGeom>
+          <a:noFill/>
+          <a:ln/>
+        </p:spPr>
+        <p:txBody>
+          <a:bodyPr wrap="square" lIns="12700" tIns="12700" rIns="12700" bIns="12700" rtlCol="0" anchor="ctr"/>
+          <a:lstStyle/>
+          <a:p>
+            <a:pPr indent="0" marL="0">
+              <a:buNone/>
+            </a:pPr>
+            <a:r>
+              <a:rPr lang="en-US" sz="750" b="1" dirty="0">
+                <a:solidFill>
+                  <a:srgbClr val="4285F4"/>
+                </a:solidFill>
+              </a:rPr>
+              <a:t>N </a:t>
+            </a:r>
+            <a:pPr indent="0" marL="0">
+              <a:buNone/>
+            </a:pPr>
+            <a:r>
+              <a:rPr lang="en-US" sz="750" dirty="0">
+                <a:solidFill>
+                  <a:srgbClr val="1A73E8"/>
+                </a:solidFill>
+              </a:rPr>
+              <a:t>Made with NotebookLM</a:t>
+            </a:r>
+            <a:endParaRPr lang="en-US" sz="750" dirty="0"/>
+          </a:p>
+        </p:txBody>
+      </p:sp>
     </p:spTree>
   </p:cSld>
   <p:clrMapOvr>
@@ -2134,14 +2206,70 @@
       </p:sp>
       <p:sp>
         <p:nvSpPr>
-          <p:cNvPr id="7" name="Text 5"/>
-          <p:cNvSpPr/>
-          <p:nvPr/>
-        </p:nvSpPr>
-        <p:spPr>
-          <a:xfrm>
-            <a:off x="502920" y="2286000"/>
-            <a:ext cx="457200" cy="365760"/>
+          <p:cNvPr id="7" name="Shape 5"/>
+          <p:cNvSpPr/>
+          <p:nvPr/>
+        </p:nvSpPr>
+        <p:spPr>
+          <a:xfrm>
+            <a:off x="457200" y="2304288"/>
+            <a:ext cx="365760" cy="365760"/>
+          </a:xfrm>
+          <a:prstGeom prst="rect">
+            <a:avLst/>
+          </a:prstGeom>
+          <a:solidFill>
+            <a:srgbClr val="1DB954"/>
+          </a:solidFill>
+          <a:ln/>
+        </p:spPr>
+      </p:sp>
+      <p:sp>
+        <p:nvSpPr>
+          <p:cNvPr id="8" name="Text 6"/>
+          <p:cNvSpPr/>
+          <p:nvPr/>
+        </p:nvSpPr>
+        <p:spPr>
+          <a:xfrm>
+            <a:off x="457200" y="2304288"/>
+            <a:ext cx="365760" cy="365760"/>
+          </a:xfrm>
+          <a:prstGeom prst="rect">
+            <a:avLst/>
+          </a:prstGeom>
+          <a:noFill/>
+          <a:ln/>
+        </p:spPr>
+        <p:txBody>
+          <a:bodyPr wrap="square" lIns="0" tIns="0" rIns="0" bIns="0" rtlCol="0" anchor="ctr"/>
+          <a:lstStyle/>
+          <a:p>
+            <a:pPr algn="ctr" indent="0" marL="0">
+              <a:buNone/>
+            </a:pPr>
+            <a:r>
+              <a:rPr lang="en-US" sz="900" b="1" dirty="0">
+                <a:solidFill>
+                  <a:srgbClr val="FFFFFF"/>
+                </a:solidFill>
+              </a:rPr>
+              <a:t>!</a:t>
+            </a:r>
+            <a:endParaRPr lang="en-US" sz="900" dirty="0"/>
+          </a:p>
+        </p:txBody>
+      </p:sp>
+      <p:sp>
+        <p:nvSpPr>
+          <p:cNvPr id="9" name="Text 7"/>
+          <p:cNvSpPr/>
+          <p:nvPr/>
+        </p:nvSpPr>
+        <p:spPr>
+          <a:xfrm>
+            <a:off x="457200" y="2743200"/>
+            <a:ext cx="2468880" cy="274320"/>
           </a:xfrm>
           <a:prstGeom prst="rect">
             <a:avLst/>
@@ -2157,42 +2285,6 @@
               <a:buNone/>
             </a:pPr>
             <a:r>
-              <a:rPr lang="en-US" sz="1800" dirty="0">
-                <a:solidFill>
-                  <a:srgbClr val="000000"/>
-                </a:solidFill>
-              </a:rPr>
-              <a:t>😤</a:t>
-            </a:r>
-            <a:endParaRPr lang="en-US" sz="1800" dirty="0"/>
-          </a:p>
-        </p:txBody>
-      </p:sp>
-      <p:sp>
-        <p:nvSpPr>
-          <p:cNvPr id="8" name="Text 6"/>
-          <p:cNvSpPr/>
-          <p:nvPr/>
-        </p:nvSpPr>
-        <p:spPr>
-          <a:xfrm>
-            <a:off x="457200" y="2633472"/>
-            <a:ext cx="2468880" cy="274320"/>
-          </a:xfrm>
-          <a:prstGeom prst="rect">
-            <a:avLst/>
-          </a:prstGeom>
-          <a:noFill/>
-          <a:ln/>
-        </p:spPr>
-        <p:txBody>
-          <a:bodyPr wrap="square" rtlCol="0" anchor="ctr"/>
-          <a:lstStyle/>
-          <a:p>
-            <a:pPr indent="0" marL="0">
-              <a:buNone/>
-            </a:pPr>
-            <a:r>
               <a:rPr lang="en-US" sz="1100" b="1" dirty="0">
                 <a:solidFill>
                   <a:srgbClr val="121212"/>
@@ -2206,14 +2298,14 @@
       </p:sp>
       <p:sp>
         <p:nvSpPr>
-          <p:cNvPr id="9" name="Text 7"/>
-          <p:cNvSpPr/>
-          <p:nvPr/>
-        </p:nvSpPr>
-        <p:spPr>
-          <a:xfrm>
-            <a:off x="457200" y="2926080"/>
-            <a:ext cx="2468880" cy="685800"/>
+          <p:cNvPr id="10" name="Text 8"/>
+          <p:cNvSpPr/>
+          <p:nvPr/>
+        </p:nvSpPr>
+        <p:spPr>
+          <a:xfrm>
+            <a:off x="457200" y="3035808"/>
+            <a:ext cx="2468880" cy="566928"/>
           </a:xfrm>
           <a:prstGeom prst="rect">
             <a:avLst/>
@@ -2245,7 +2337,7 @@
       </p:sp>
       <p:sp>
         <p:nvSpPr>
-          <p:cNvPr id="10" name="Shape 8"/>
+          <p:cNvPr id="11" name="Shape 9"/>
           <p:cNvSpPr/>
           <p:nvPr/>
         </p:nvSpPr>
@@ -2272,14 +2364,70 @@
       </p:sp>
       <p:sp>
         <p:nvSpPr>
-          <p:cNvPr id="11" name="Text 9"/>
-          <p:cNvSpPr/>
-          <p:nvPr/>
-        </p:nvSpPr>
-        <p:spPr>
-          <a:xfrm>
-            <a:off x="3337560" y="2286000"/>
-            <a:ext cx="457200" cy="365760"/>
+          <p:cNvPr id="12" name="Shape 10"/>
+          <p:cNvSpPr/>
+          <p:nvPr/>
+        </p:nvSpPr>
+        <p:spPr>
+          <a:xfrm>
+            <a:off x="3291840" y="2304288"/>
+            <a:ext cx="365760" cy="365760"/>
+          </a:xfrm>
+          <a:prstGeom prst="rect">
+            <a:avLst/>
+          </a:prstGeom>
+          <a:solidFill>
+            <a:srgbClr val="1DB954"/>
+          </a:solidFill>
+          <a:ln/>
+        </p:spPr>
+      </p:sp>
+      <p:sp>
+        <p:nvSpPr>
+          <p:cNvPr id="13" name="Text 11"/>
+          <p:cNvSpPr/>
+          <p:nvPr/>
+        </p:nvSpPr>
+        <p:spPr>
+          <a:xfrm>
+            <a:off x="3291840" y="2304288"/>
+            <a:ext cx="365760" cy="365760"/>
+          </a:xfrm>
+          <a:prstGeom prst="rect">
+            <a:avLst/>
+          </a:prstGeom>
+          <a:noFill/>
+          <a:ln/>
+        </p:spPr>
+        <p:txBody>
+          <a:bodyPr wrap="square" lIns="0" tIns="0" rIns="0" bIns="0" rtlCol="0" anchor="ctr"/>
+          <a:lstStyle/>
+          <a:p>
+            <a:pPr algn="ctr" indent="0" marL="0">
+              <a:buNone/>
+            </a:pPr>
+            <a:r>
+              <a:rPr lang="en-US" sz="900" b="1" dirty="0">
+                <a:solidFill>
+                  <a:srgbClr val="FFFFFF"/>
+                </a:solidFill>
+              </a:rPr>
+              <a:t>~</a:t>
+            </a:r>
+            <a:endParaRPr lang="en-US" sz="900" dirty="0"/>
+          </a:p>
+        </p:txBody>
+      </p:sp>
+      <p:sp>
+        <p:nvSpPr>
+          <p:cNvPr id="14" name="Text 12"/>
+          <p:cNvSpPr/>
+          <p:nvPr/>
+        </p:nvSpPr>
+        <p:spPr>
+          <a:xfrm>
+            <a:off x="3291840" y="2743200"/>
+            <a:ext cx="2468880" cy="274320"/>
           </a:xfrm>
           <a:prstGeom prst="rect">
             <a:avLst/>
@@ -2295,42 +2443,6 @@
               <a:buNone/>
             </a:pPr>
             <a:r>
-              <a:rPr lang="en-US" sz="1800" dirty="0">
-                <a:solidFill>
-                  <a:srgbClr val="000000"/>
-                </a:solidFill>
-              </a:rPr>
-              <a:t>🎵</a:t>
-            </a:r>
-            <a:endParaRPr lang="en-US" sz="1800" dirty="0"/>
-          </a:p>
-        </p:txBody>
-      </p:sp>
-      <p:sp>
-        <p:nvSpPr>
-          <p:cNvPr id="12" name="Text 10"/>
-          <p:cNvSpPr/>
-          <p:nvPr/>
-        </p:nvSpPr>
-        <p:spPr>
-          <a:xfrm>
-            <a:off x="3291840" y="2633472"/>
-            <a:ext cx="2468880" cy="274320"/>
-          </a:xfrm>
-          <a:prstGeom prst="rect">
-            <a:avLst/>
-          </a:prstGeom>
-          <a:noFill/>
-          <a:ln/>
-        </p:spPr>
-        <p:txBody>
-          <a:bodyPr wrap="square" rtlCol="0" anchor="ctr"/>
-          <a:lstStyle/>
-          <a:p>
-            <a:pPr indent="0" marL="0">
-              <a:buNone/>
-            </a:pPr>
-            <a:r>
               <a:rPr lang="en-US" sz="1100" b="1" dirty="0">
                 <a:solidFill>
                   <a:srgbClr val="121212"/>
@@ -2344,14 +2456,14 @@
       </p:sp>
       <p:sp>
         <p:nvSpPr>
-          <p:cNvPr id="13" name="Text 11"/>
-          <p:cNvSpPr/>
-          <p:nvPr/>
-        </p:nvSpPr>
-        <p:spPr>
-          <a:xfrm>
-            <a:off x="3291840" y="2926080"/>
-            <a:ext cx="2468880" cy="685800"/>
+          <p:cNvPr id="15" name="Text 13"/>
+          <p:cNvSpPr/>
+          <p:nvPr/>
+        </p:nvSpPr>
+        <p:spPr>
+          <a:xfrm>
+            <a:off x="3291840" y="3035808"/>
+            <a:ext cx="2468880" cy="566928"/>
           </a:xfrm>
           <a:prstGeom prst="rect">
             <a:avLst/>
@@ -2383,7 +2495,7 @@
       </p:sp>
       <p:sp>
         <p:nvSpPr>
-          <p:cNvPr id="14" name="Shape 12"/>
+          <p:cNvPr id="16" name="Shape 14"/>
           <p:cNvSpPr/>
           <p:nvPr/>
         </p:nvSpPr>
@@ -2410,14 +2522,70 @@
       </p:sp>
       <p:sp>
         <p:nvSpPr>
-          <p:cNvPr id="15" name="Text 13"/>
-          <p:cNvSpPr/>
-          <p:nvPr/>
-        </p:nvSpPr>
-        <p:spPr>
-          <a:xfrm>
-            <a:off x="6172200" y="2286000"/>
-            <a:ext cx="457200" cy="365760"/>
+          <p:cNvPr id="17" name="Shape 15"/>
+          <p:cNvSpPr/>
+          <p:nvPr/>
+        </p:nvSpPr>
+        <p:spPr>
+          <a:xfrm>
+            <a:off x="6126480" y="2304288"/>
+            <a:ext cx="365760" cy="365760"/>
+          </a:xfrm>
+          <a:prstGeom prst="rect">
+            <a:avLst/>
+          </a:prstGeom>
+          <a:solidFill>
+            <a:srgbClr val="1DB954"/>
+          </a:solidFill>
+          <a:ln/>
+        </p:spPr>
+      </p:sp>
+      <p:sp>
+        <p:nvSpPr>
+          <p:cNvPr id="18" name="Text 16"/>
+          <p:cNvSpPr/>
+          <p:nvPr/>
+        </p:nvSpPr>
+        <p:spPr>
+          <a:xfrm>
+            <a:off x="6126480" y="2304288"/>
+            <a:ext cx="365760" cy="365760"/>
+          </a:xfrm>
+          <a:prstGeom prst="rect">
+            <a:avLst/>
+          </a:prstGeom>
+          <a:noFill/>
+          <a:ln/>
+        </p:spPr>
+        <p:txBody>
+          <a:bodyPr wrap="square" lIns="0" tIns="0" rIns="0" bIns="0" rtlCol="0" anchor="ctr"/>
+          <a:lstStyle/>
+          <a:p>
+            <a:pPr algn="ctr" indent="0" marL="0">
+              <a:buNone/>
+            </a:pPr>
+            <a:r>
+              <a:rPr lang="en-US" sz="900" b="1" dirty="0">
+                <a:solidFill>
+                  <a:srgbClr val="FFFFFF"/>
+                </a:solidFill>
+              </a:rPr>
+              <a:t>$</a:t>
+            </a:r>
+            <a:endParaRPr lang="en-US" sz="900" dirty="0"/>
+          </a:p>
+        </p:txBody>
+      </p:sp>
+      <p:sp>
+        <p:nvSpPr>
+          <p:cNvPr id="19" name="Text 17"/>
+          <p:cNvSpPr/>
+          <p:nvPr/>
+        </p:nvSpPr>
+        <p:spPr>
+          <a:xfrm>
+            <a:off x="6126480" y="2743200"/>
+            <a:ext cx="2468880" cy="274320"/>
           </a:xfrm>
           <a:prstGeom prst="rect">
             <a:avLst/>
@@ -2433,42 +2601,6 @@
               <a:buNone/>
             </a:pPr>
             <a:r>
-              <a:rPr lang="en-US" sz="1800" dirty="0">
-                <a:solidFill>
-                  <a:srgbClr val="000000"/>
-                </a:solidFill>
-              </a:rPr>
-              <a:t>💸</a:t>
-            </a:r>
-            <a:endParaRPr lang="en-US" sz="1800" dirty="0"/>
-          </a:p>
-        </p:txBody>
-      </p:sp>
-      <p:sp>
-        <p:nvSpPr>
-          <p:cNvPr id="16" name="Text 14"/>
-          <p:cNvSpPr/>
-          <p:nvPr/>
-        </p:nvSpPr>
-        <p:spPr>
-          <a:xfrm>
-            <a:off x="6126480" y="2633472"/>
-            <a:ext cx="2468880" cy="274320"/>
-          </a:xfrm>
-          <a:prstGeom prst="rect">
-            <a:avLst/>
-          </a:prstGeom>
-          <a:noFill/>
-          <a:ln/>
-        </p:spPr>
-        <p:txBody>
-          <a:bodyPr wrap="square" rtlCol="0" anchor="ctr"/>
-          <a:lstStyle/>
-          <a:p>
-            <a:pPr indent="0" marL="0">
-              <a:buNone/>
-            </a:pPr>
-            <a:r>
               <a:rPr lang="en-US" sz="1100" b="1" dirty="0">
                 <a:solidFill>
                   <a:srgbClr val="121212"/>
@@ -2482,14 +2614,14 @@
       </p:sp>
       <p:sp>
         <p:nvSpPr>
-          <p:cNvPr id="17" name="Text 15"/>
-          <p:cNvSpPr/>
-          <p:nvPr/>
-        </p:nvSpPr>
-        <p:spPr>
-          <a:xfrm>
-            <a:off x="6126480" y="2926080"/>
-            <a:ext cx="2468880" cy="685800"/>
+          <p:cNvPr id="20" name="Text 18"/>
+          <p:cNvSpPr/>
+          <p:nvPr/>
+        </p:nvSpPr>
+        <p:spPr>
+          <a:xfrm>
+            <a:off x="6126480" y="3035808"/>
+            <a:ext cx="2468880" cy="566928"/>
           </a:xfrm>
           <a:prstGeom prst="rect">
             <a:avLst/>
@@ -2521,7 +2653,7 @@
       </p:sp>
       <p:sp>
         <p:nvSpPr>
-          <p:cNvPr id="18" name="Text 16"/>
+          <p:cNvPr id="21" name="Text 19"/>
           <p:cNvSpPr/>
           <p:nvPr/>
         </p:nvSpPr>
@@ -2557,7 +2689,7 @@
       </p:sp>
       <p:sp>
         <p:nvSpPr>
-          <p:cNvPr id="19" name="Shape 17"/>
+          <p:cNvPr id="22" name="Shape 20"/>
           <p:cNvSpPr/>
           <p:nvPr/>
         </p:nvSpPr>
@@ -2577,7 +2709,7 @@
       </p:sp>
       <p:sp>
         <p:nvSpPr>
-          <p:cNvPr id="20" name="Text 18"/>
+          <p:cNvPr id="23" name="Text 21"/>
           <p:cNvSpPr/>
           <p:nvPr/>
         </p:nvSpPr>
@@ -2613,7 +2745,7 @@
       </p:sp>
       <p:sp>
         <p:nvSpPr>
-          <p:cNvPr id="21" name="Text 19"/>
+          <p:cNvPr id="24" name="Text 22"/>
           <p:cNvSpPr/>
           <p:nvPr/>
         </p:nvSpPr>
@@ -2652,7 +2784,7 @@
       </p:sp>
       <p:sp>
         <p:nvSpPr>
-          <p:cNvPr id="22" name="Shape 20"/>
+          <p:cNvPr id="25" name="Shape 23"/>
           <p:cNvSpPr/>
           <p:nvPr/>
         </p:nvSpPr>
@@ -2672,7 +2804,7 @@
       </p:sp>
       <p:sp>
         <p:nvSpPr>
-          <p:cNvPr id="23" name="Text 21"/>
+          <p:cNvPr id="26" name="Text 24"/>
           <p:cNvSpPr/>
           <p:nvPr/>
         </p:nvSpPr>
@@ -2708,7 +2840,7 @@
       </p:sp>
       <p:sp>
         <p:nvSpPr>
-          <p:cNvPr id="24" name="Text 22"/>
+          <p:cNvPr id="27" name="Text 25"/>
           <p:cNvSpPr/>
           <p:nvPr/>
         </p:nvSpPr>
@@ -2747,7 +2879,7 @@
       </p:sp>
       <p:sp>
         <p:nvSpPr>
-          <p:cNvPr id="25" name="Shape 23"/>
+          <p:cNvPr id="28" name="Shape 26"/>
           <p:cNvSpPr/>
           <p:nvPr/>
         </p:nvSpPr>
@@ -2767,7 +2899,7 @@
       </p:sp>
       <p:sp>
         <p:nvSpPr>
-          <p:cNvPr id="26" name="Text 24"/>
+          <p:cNvPr id="29" name="Text 27"/>
           <p:cNvSpPr/>
           <p:nvPr/>
         </p:nvSpPr>
@@ -2803,7 +2935,7 @@
       </p:sp>
       <p:sp>
         <p:nvSpPr>
-          <p:cNvPr id="27" name="Text 25"/>
+          <p:cNvPr id="30" name="Text 28"/>
           <p:cNvSpPr/>
           <p:nvPr/>
         </p:nvSpPr>
@@ -2837,6 +2969,78 @@
               <a:t>Curate by emotion. Feel unheard by current AI playlists.</a:t>
             </a:r>
             <a:endParaRPr lang="en-US" sz="850" dirty="0"/>
+          </a:p>
+        </p:txBody>
+      </p:sp>
+      <p:sp>
+        <p:nvSpPr>
+          <p:cNvPr id="31" name="Shape 29"/>
+          <p:cNvSpPr/>
+          <p:nvPr/>
+        </p:nvSpPr>
+        <p:spPr>
+          <a:xfrm>
+            <a:off x="7132320" y="4919472"/>
+            <a:ext cx="1965960" cy="201168"/>
+          </a:xfrm>
+          <a:prstGeom prst="rect">
+            <a:avLst/>
+          </a:prstGeom>
+          <a:solidFill>
+            <a:srgbClr val="E8F4FD"/>
+          </a:solidFill>
+          <a:ln w="6350">
+            <a:solidFill>
+              <a:srgbClr val="4285F4"/>
+            </a:solidFill>
+            <a:prstDash val="solid"/>
+          </a:ln>
+        </p:spPr>
+      </p:sp>
+      <p:sp>
+        <p:nvSpPr>
+          <p:cNvPr id="32" name="Text 30"/>
+          <p:cNvSpPr/>
+          <p:nvPr/>
+        </p:nvSpPr>
+        <p:spPr>
+          <a:xfrm>
+            <a:off x="7150608" y="4924044"/>
+            <a:ext cx="1920240" cy="182880"/>
+          </a:xfrm>
+          <a:prstGeom prst="rect">
+            <a:avLst/>
+          </a:prstGeom>
+          <a:noFill/>
+          <a:ln/>
+        </p:spPr>
+        <p:txBody>
+          <a:bodyPr wrap="square" lIns="12700" tIns="12700" rIns="12700" bIns="12700" rtlCol="0" anchor="ctr"/>
+          <a:lstStyle/>
+          <a:p>
+            <a:pPr indent="0" marL="0">
+              <a:buNone/>
+            </a:pPr>
+            <a:r>
+              <a:rPr lang="en-US" sz="750" b="1" dirty="0">
+                <a:solidFill>
+                  <a:srgbClr val="4285F4"/>
+                </a:solidFill>
+              </a:rPr>
+              <a:t>N </a:t>
+            </a:r>
+            <a:pPr indent="0" marL="0">
+              <a:buNone/>
+            </a:pPr>
+            <a:r>
+              <a:rPr lang="en-US" sz="750" dirty="0">
+                <a:solidFill>
+                  <a:srgbClr val="1A73E8"/>
+                </a:solidFill>
+              </a:rPr>
+              <a:t>Made with NotebookLM</a:t>
+            </a:r>
+            <a:endParaRPr lang="en-US" sz="750" dirty="0"/>
           </a:p>
         </p:txBody>
       </p:sp>
@@ -3024,7 +3228,7 @@
                   <a:srgbClr val="F87171"/>
                 </a:solidFill>
               </a:rPr>
-              <a:t>✗  </a:t>
+              <a:t>X  </a:t>
             </a:r>
             <a:pPr indent="0" marL="0">
               <a:lnSpc>
@@ -3077,7 +3281,7 @@
                   <a:srgbClr val="F87171"/>
                 </a:solidFill>
               </a:rPr>
-              <a:t>✗  </a:t>
+              <a:t>X  </a:t>
             </a:r>
             <a:pPr indent="0" marL="0">
               <a:lnSpc>
@@ -3130,7 +3334,7 @@
                   <a:srgbClr val="F87171"/>
                 </a:solidFill>
               </a:rPr>
-              <a:t>✗  </a:t>
+              <a:t>X  </a:t>
             </a:r>
             <a:pPr indent="0" marL="0">
               <a:lnSpc>
@@ -3183,7 +3387,7 @@
                   <a:srgbClr val="F87171"/>
                 </a:solidFill>
               </a:rPr>
-              <a:t>✗  </a:t>
+              <a:t>X  </a:t>
             </a:r>
             <a:pPr indent="0" marL="0">
               <a:lnSpc>
@@ -3299,7 +3503,7 @@
                   <a:srgbClr val="1ED760"/>
                 </a:solidFill>
               </a:rPr>
-              <a:t>✓  Emotional Context Understanding
+              <a:t>[v]  Emotional Context Understanding
 </a:t>
             </a:r>
             <a:pPr indent="0" marL="0">
@@ -3353,7 +3557,7 @@
                   <a:srgbClr val="1ED760"/>
                 </a:solidFill>
               </a:rPr>
-              <a:t>✓  Dynamic Narrative Curation
+              <a:t>[v]  Dynamic Narrative Curation
 </a:t>
             </a:r>
             <a:pPr indent="0" marL="0">
@@ -3407,7 +3611,7 @@
                   <a:srgbClr val="1ED760"/>
                 </a:solidFill>
               </a:rPr>
-              <a:t>✓  Conversational Discovery
+              <a:t>[v]  Conversational Discovery
 </a:t>
             </a:r>
             <a:pPr indent="0" marL="0">
@@ -3461,7 +3665,7 @@
                   <a:srgbClr val="1ED760"/>
                 </a:solidFill>
               </a:rPr>
-              <a:t>✓  Generative Content Layer
+              <a:t>[v]  Generative Content Layer
 </a:t>
             </a:r>
             <a:pPr indent="0" marL="0">
@@ -3479,6 +3683,78 @@
               <a:t>    AI-written liner notes, artist bios, mood transitions narrated intelligently</a:t>
             </a:r>
             <a:endParaRPr lang="en-US" sz="1000" dirty="0"/>
+          </a:p>
+        </p:txBody>
+      </p:sp>
+      <p:sp>
+        <p:nvSpPr>
+          <p:cNvPr id="16" name="Shape 14"/>
+          <p:cNvSpPr/>
+          <p:nvPr/>
+        </p:nvSpPr>
+        <p:spPr>
+          <a:xfrm>
+            <a:off x="7132320" y="4919472"/>
+            <a:ext cx="1965960" cy="201168"/>
+          </a:xfrm>
+          <a:prstGeom prst="rect">
+            <a:avLst/>
+          </a:prstGeom>
+          <a:solidFill>
+            <a:srgbClr val="E8F4FD"/>
+          </a:solidFill>
+          <a:ln w="6350">
+            <a:solidFill>
+              <a:srgbClr val="4285F4"/>
+            </a:solidFill>
+            <a:prstDash val="solid"/>
+          </a:ln>
+        </p:spPr>
+      </p:sp>
+      <p:sp>
+        <p:nvSpPr>
+          <p:cNvPr id="17" name="Text 15"/>
+          <p:cNvSpPr/>
+          <p:nvPr/>
+        </p:nvSpPr>
+        <p:spPr>
+          <a:xfrm>
+            <a:off x="7150608" y="4924044"/>
+            <a:ext cx="1920240" cy="182880"/>
+          </a:xfrm>
+          <a:prstGeom prst="rect">
+            <a:avLst/>
+          </a:prstGeom>
+          <a:noFill/>
+          <a:ln/>
+        </p:spPr>
+        <p:txBody>
+          <a:bodyPr wrap="square" lIns="12700" tIns="12700" rIns="12700" bIns="12700" rtlCol="0" anchor="ctr"/>
+          <a:lstStyle/>
+          <a:p>
+            <a:pPr indent="0" marL="0">
+              <a:buNone/>
+            </a:pPr>
+            <a:r>
+              <a:rPr lang="en-US" sz="750" b="1" dirty="0">
+                <a:solidFill>
+                  <a:srgbClr val="4285F4"/>
+                </a:solidFill>
+              </a:rPr>
+              <a:t>N </a:t>
+            </a:r>
+            <a:pPr indent="0" marL="0">
+              <a:buNone/>
+            </a:pPr>
+            <a:r>
+              <a:rPr lang="en-US" sz="750" dirty="0">
+                <a:solidFill>
+                  <a:srgbClr val="1A73E8"/>
+                </a:solidFill>
+              </a:rPr>
+              <a:t>Made with NotebookLM</a:t>
+            </a:r>
+            <a:endParaRPr lang="en-US" sz="750" dirty="0"/>
           </a:p>
         </p:txBody>
       </p:sp>
@@ -3749,7 +4025,7 @@
                   <a:srgbClr val="1DB954"/>
                 </a:solidFill>
               </a:rPr>
-              <a:t>🎭  MoodSync AI</a:t>
+              <a:t>[Mood]  MoodSync AI</a:t>
             </a:r>
             <a:endParaRPr lang="en-US" sz="1250" dirty="0"/>
           </a:p>
@@ -3880,7 +4156,7 @@
                   <a:srgbClr val="121212"/>
                 </a:solidFill>
               </a:rPr>
-              <a:t>📈 +22% session length</a:t>
+              <a:t>[+] +22% session length</a:t>
             </a:r>
             <a:endParaRPr lang="en-US" sz="1000" dirty="0"/>
           </a:p>
@@ -3963,7 +4239,7 @@
                   <a:srgbClr val="1DB954"/>
                 </a:solidFill>
               </a:rPr>
-              <a:t>🌦️  Context Conductor</a:t>
+              <a:t>[Context]️  Context Conductor</a:t>
             </a:r>
             <a:endParaRPr lang="en-US" sz="1250" dirty="0"/>
           </a:p>
@@ -4094,7 +4370,7 @@
                   <a:srgbClr val="121212"/>
                 </a:solidFill>
               </a:rPr>
-              <a:t>📈 +18% retention</a:t>
+              <a:t>[+] +18% retention</a:t>
             </a:r>
             <a:endParaRPr lang="en-US" sz="1000" dirty="0"/>
           </a:p>
@@ -4177,7 +4453,7 @@
                   <a:srgbClr val="1DB954"/>
                 </a:solidFill>
               </a:rPr>
-              <a:t>🔍  Discovery Dialogue</a:t>
+              <a:t>[Search]  Discovery Dialogue</a:t>
             </a:r>
             <a:endParaRPr lang="en-US" sz="1250" dirty="0"/>
           </a:p>
@@ -4308,7 +4584,7 @@
                   <a:srgbClr val="121212"/>
                 </a:solidFill>
               </a:rPr>
-              <a:t>📈 +31% new artist streams</a:t>
+              <a:t>[+] +31% new artist streams</a:t>
             </a:r>
             <a:endParaRPr lang="en-US" sz="1000" dirty="0"/>
           </a:p>
@@ -5185,7 +5461,7 @@
                   <a:srgbClr val="1ED760"/>
                 </a:solidFill>
               </a:rPr>
-              <a:t>🎙️ Voice Mood Check-In</a:t>
+              <a:t>[Mic]️ Voice Mood Check-In</a:t>
             </a:r>
             <a:endParaRPr lang="en-US" sz="1050" dirty="0"/>
           </a:p>
@@ -5287,7 +5563,7 @@
                   <a:srgbClr val="1ED760"/>
                 </a:solidFill>
               </a:rPr>
-              <a:t>🤖 Autonomous Session Agent</a:t>
+              <a:t>[AI] Autonomous Session Agent</a:t>
             </a:r>
             <a:endParaRPr lang="en-US" sz="1050" dirty="0"/>
           </a:p>
@@ -5389,7 +5665,7 @@
                   <a:srgbClr val="1ED760"/>
                 </a:solidFill>
               </a:rPr>
-              <a:t>💬 Conversational Discovery</a:t>
+              <a:t>[Chat] Conversational Discovery</a:t>
             </a:r>
             <a:endParaRPr lang="en-US" sz="1050" dirty="0"/>
           </a:p>
@@ -5491,7 +5767,7 @@
                   <a:srgbClr val="1ED760"/>
                 </a:solidFill>
               </a:rPr>
-              <a:t>✍️ AI Liner Notes</a:t>
+              <a:t>[Write]️ AI Liner Notes</a:t>
             </a:r>
             <a:endParaRPr lang="en-US" sz="1050" dirty="0"/>
           </a:p>
@@ -5533,6 +5809,78 @@
               <a:t>Each AI playlist includes a generated narrative: why these songs, what the arc is, artist context. Increases engagement and perceived value of the AI curation.</a:t>
             </a:r>
             <a:endParaRPr lang="en-US" sz="850" dirty="0"/>
+          </a:p>
+        </p:txBody>
+      </p:sp>
+      <p:sp>
+        <p:nvSpPr>
+          <p:cNvPr id="37" name="Shape 35"/>
+          <p:cNvSpPr/>
+          <p:nvPr/>
+        </p:nvSpPr>
+        <p:spPr>
+          <a:xfrm>
+            <a:off x="7132320" y="4919472"/>
+            <a:ext cx="1965960" cy="201168"/>
+          </a:xfrm>
+          <a:prstGeom prst="rect">
+            <a:avLst/>
+          </a:prstGeom>
+          <a:solidFill>
+            <a:srgbClr val="E8F4FD"/>
+          </a:solidFill>
+          <a:ln w="6350">
+            <a:solidFill>
+              <a:srgbClr val="4285F4"/>
+            </a:solidFill>
+            <a:prstDash val="solid"/>
+          </a:ln>
+        </p:spPr>
+      </p:sp>
+      <p:sp>
+        <p:nvSpPr>
+          <p:cNvPr id="38" name="Text 36"/>
+          <p:cNvSpPr/>
+          <p:nvPr/>
+        </p:nvSpPr>
+        <p:spPr>
+          <a:xfrm>
+            <a:off x="7150608" y="4924044"/>
+            <a:ext cx="1920240" cy="182880"/>
+          </a:xfrm>
+          <a:prstGeom prst="rect">
+            <a:avLst/>
+          </a:prstGeom>
+          <a:noFill/>
+          <a:ln/>
+        </p:spPr>
+        <p:txBody>
+          <a:bodyPr wrap="square" lIns="12700" tIns="12700" rIns="12700" bIns="12700" rtlCol="0" anchor="ctr"/>
+          <a:lstStyle/>
+          <a:p>
+            <a:pPr indent="0" marL="0">
+              <a:buNone/>
+            </a:pPr>
+            <a:r>
+              <a:rPr lang="en-US" sz="750" b="1" dirty="0">
+                <a:solidFill>
+                  <a:srgbClr val="4285F4"/>
+                </a:solidFill>
+              </a:rPr>
+              <a:t>N </a:t>
+            </a:r>
+            <a:pPr indent="0" marL="0">
+              <a:buNone/>
+            </a:pPr>
+            <a:r>
+              <a:rPr lang="en-US" sz="750" dirty="0">
+                <a:solidFill>
+                  <a:srgbClr val="1A73E8"/>
+                </a:solidFill>
+              </a:rPr>
+              <a:t>Made with NotebookLM</a:t>
+            </a:r>
+            <a:endParaRPr lang="en-US" sz="750" dirty="0"/>
           </a:p>
         </p:txBody>
       </p:sp>
@@ -6449,7 +6797,7 @@
                   <a:srgbClr val="92400E"/>
                 </a:solidFill>
               </a:rPr>
-              <a:t>⚠ Hallucinations</a:t>
+              <a:t>[!] Hallucinations</a:t>
             </a:r>
             <a:endParaRPr lang="en-US" sz="1000" dirty="0"/>
           </a:p>
@@ -6551,7 +6899,7 @@
                   <a:srgbClr val="92400E"/>
                 </a:solidFill>
               </a:rPr>
-              <a:t>⚠ Privacy (context data)</a:t>
+              <a:t>[!] Privacy (context data)</a:t>
             </a:r>
             <a:endParaRPr lang="en-US" sz="1000" dirty="0"/>
           </a:p>
@@ -6653,7 +7001,7 @@
                   <a:srgbClr val="92400E"/>
                 </a:solidFill>
               </a:rPr>
-              <a:t>⚠ Latency</a:t>
+              <a:t>[!] Latency</a:t>
             </a:r>
             <a:endParaRPr lang="en-US" sz="1000" dirty="0"/>
           </a:p>
@@ -6755,7 +7103,7 @@
                   <a:srgbClr val="92400E"/>
                 </a:solidFill>
               </a:rPr>
-              <a:t>⚠ User Trust</a:t>
+              <a:t>[!] User Trust</a:t>
             </a:r>
             <a:endParaRPr lang="en-US" sz="1000" dirty="0"/>
           </a:p>
@@ -6857,7 +7205,7 @@
                   <a:srgbClr val="92400E"/>
                 </a:solidFill>
               </a:rPr>
-              <a:t>⚠ Adoption</a:t>
+              <a:t>[!] Adoption</a:t>
             </a:r>
             <a:endParaRPr lang="en-US" sz="1000" dirty="0"/>
           </a:p>
@@ -6899,6 +7247,78 @@
               <a:t>Progressive rollout: start with AI Liner Notes (low risk, high delight), then unlock agents for opted-in users after trust is built.</a:t>
             </a:r>
             <a:endParaRPr lang="en-US" sz="850" dirty="0"/>
+          </a:p>
+        </p:txBody>
+      </p:sp>
+      <p:sp>
+        <p:nvSpPr>
+          <p:cNvPr id="41" name="Shape 39"/>
+          <p:cNvSpPr/>
+          <p:nvPr/>
+        </p:nvSpPr>
+        <p:spPr>
+          <a:xfrm>
+            <a:off x="7132320" y="4919472"/>
+            <a:ext cx="1965960" cy="201168"/>
+          </a:xfrm>
+          <a:prstGeom prst="rect">
+            <a:avLst/>
+          </a:prstGeom>
+          <a:solidFill>
+            <a:srgbClr val="E8F4FD"/>
+          </a:solidFill>
+          <a:ln w="6350">
+            <a:solidFill>
+              <a:srgbClr val="4285F4"/>
+            </a:solidFill>
+            <a:prstDash val="solid"/>
+          </a:ln>
+        </p:spPr>
+      </p:sp>
+      <p:sp>
+        <p:nvSpPr>
+          <p:cNvPr id="42" name="Text 40"/>
+          <p:cNvSpPr/>
+          <p:nvPr/>
+        </p:nvSpPr>
+        <p:spPr>
+          <a:xfrm>
+            <a:off x="7150608" y="4924044"/>
+            <a:ext cx="1920240" cy="182880"/>
+          </a:xfrm>
+          <a:prstGeom prst="rect">
+            <a:avLst/>
+          </a:prstGeom>
+          <a:noFill/>
+          <a:ln/>
+        </p:spPr>
+        <p:txBody>
+          <a:bodyPr wrap="square" lIns="12700" tIns="12700" rIns="12700" bIns="12700" rtlCol="0" anchor="ctr"/>
+          <a:lstStyle/>
+          <a:p>
+            <a:pPr indent="0" marL="0">
+              <a:buNone/>
+            </a:pPr>
+            <a:r>
+              <a:rPr lang="en-US" sz="750" b="1" dirty="0">
+                <a:solidFill>
+                  <a:srgbClr val="4285F4"/>
+                </a:solidFill>
+              </a:rPr>
+              <a:t>N </a:t>
+            </a:r>
+            <a:pPr indent="0" marL="0">
+              <a:buNone/>
+            </a:pPr>
+            <a:r>
+              <a:rPr lang="en-US" sz="750" dirty="0">
+                <a:solidFill>
+                  <a:srgbClr val="1A73E8"/>
+                </a:solidFill>
+              </a:rPr>
+              <a:t>Made with NotebookLM</a:t>
+            </a:r>
+            <a:endParaRPr lang="en-US" sz="750" dirty="0"/>
           </a:p>
         </p:txBody>
       </p:sp>

</xml_diff>